<commit_message>
Update PowerPoint for song #197 in FUBC - Українські
</commit_message>
<xml_diff>
--- a/fubc-ua/197-Хай земля вся твердо знає (Пісні Спасенних №195).pptx
+++ b/fubc-ua/197-Хай земля вся твердо знає (Пісні Спасенних №195).pptx
@@ -2174,7 +2174,7 @@
         </p:nvSpPr>
         <p:spPr>
           <a:xfrm>
-            <a:off x="1629791" y="4340352"/>
+            <a:off x="1728851" y="4340352"/>
             <a:ext cx="0" cy="594360"/>
           </a:xfrm>
           <a:prstGeom prst="line">
@@ -2197,7 +2197,7 @@
         </p:nvSpPr>
         <p:spPr>
           <a:xfrm>
-            <a:off x="10568305" y="4340352"/>
+            <a:off x="10469245" y="4340352"/>
             <a:ext cx="0" cy="594360"/>
           </a:xfrm>
           <a:prstGeom prst="line">
@@ -2220,8 +2220,8 @@
         </p:nvSpPr>
         <p:spPr>
           <a:xfrm>
-            <a:off x="10700385" y="4406392"/>
-            <a:ext cx="792480" cy="462280"/>
+            <a:off x="10568305" y="4317492"/>
+            <a:ext cx="1097280" cy="640080"/>
           </a:xfrm>
           <a:prstGeom prst="rect">
             <a:avLst/>
@@ -2237,9 +2237,9 @@
               <a:buNone/>
             </a:pPr>
             <a:r>
-              <a:rPr lang="en-US" sz="2600" b="1" dirty="0">
-                <a:solidFill>
-                  <a:srgbClr val="8A8A8A"/>
+              <a:rPr lang="en-US" sz="3600" b="1" dirty="0">
+                <a:solidFill>
+                  <a:srgbClr val="BBBBBB"/>
                 </a:solidFill>
                 <a:latin typeface="Arial" pitchFamily="34" charset="0"/>
                 <a:ea typeface="Arial" pitchFamily="34" charset="-122"/>
@@ -2247,7 +2247,7 @@
               </a:rPr>
               <a:t>×2</a:t>
             </a:r>
-            <a:endParaRPr lang="en-US" sz="2600" dirty="0"/>
+            <a:endParaRPr lang="en-US" sz="3600" dirty="0"/>
           </a:p>
         </p:txBody>
       </p:sp>
@@ -2586,7 +2586,7 @@
         </p:nvSpPr>
         <p:spPr>
           <a:xfrm>
-            <a:off x="1629791" y="4340352"/>
+            <a:off x="1728851" y="4340352"/>
             <a:ext cx="0" cy="594360"/>
           </a:xfrm>
           <a:prstGeom prst="line">
@@ -2609,7 +2609,7 @@
         </p:nvSpPr>
         <p:spPr>
           <a:xfrm>
-            <a:off x="10568305" y="4340352"/>
+            <a:off x="10469245" y="4340352"/>
             <a:ext cx="0" cy="594360"/>
           </a:xfrm>
           <a:prstGeom prst="line">
@@ -2632,8 +2632,8 @@
         </p:nvSpPr>
         <p:spPr>
           <a:xfrm>
-            <a:off x="10700385" y="4406392"/>
-            <a:ext cx="792480" cy="462280"/>
+            <a:off x="10568305" y="4317492"/>
+            <a:ext cx="1097280" cy="640080"/>
           </a:xfrm>
           <a:prstGeom prst="rect">
             <a:avLst/>
@@ -2649,9 +2649,9 @@
               <a:buNone/>
             </a:pPr>
             <a:r>
-              <a:rPr lang="en-US" sz="2600" b="1" dirty="0">
-                <a:solidFill>
-                  <a:srgbClr val="8A8A8A"/>
+              <a:rPr lang="en-US" sz="3600" b="1" dirty="0">
+                <a:solidFill>
+                  <a:srgbClr val="BBBBBB"/>
                 </a:solidFill>
                 <a:latin typeface="Arial" pitchFamily="34" charset="0"/>
                 <a:ea typeface="Arial" pitchFamily="34" charset="-122"/>
@@ -2659,7 +2659,7 @@
               </a:rPr>
               <a:t>×2</a:t>
             </a:r>
-            <a:endParaRPr lang="en-US" sz="2600" dirty="0"/>
+            <a:endParaRPr lang="en-US" sz="3600" dirty="0"/>
           </a:p>
         </p:txBody>
       </p:sp>
@@ -2927,7 +2927,7 @@
         </p:nvSpPr>
         <p:spPr>
           <a:xfrm>
-            <a:off x="1629791" y="4340352"/>
+            <a:off x="1728851" y="4340352"/>
             <a:ext cx="0" cy="594360"/>
           </a:xfrm>
           <a:prstGeom prst="line">
@@ -2950,7 +2950,7 @@
         </p:nvSpPr>
         <p:spPr>
           <a:xfrm>
-            <a:off x="10568305" y="4340352"/>
+            <a:off x="10469245" y="4340352"/>
             <a:ext cx="0" cy="594360"/>
           </a:xfrm>
           <a:prstGeom prst="line">
@@ -2973,8 +2973,8 @@
         </p:nvSpPr>
         <p:spPr>
           <a:xfrm>
-            <a:off x="10700385" y="4406392"/>
-            <a:ext cx="792480" cy="462280"/>
+            <a:off x="10568305" y="4317492"/>
+            <a:ext cx="1097280" cy="640080"/>
           </a:xfrm>
           <a:prstGeom prst="rect">
             <a:avLst/>
@@ -2990,9 +2990,9 @@
               <a:buNone/>
             </a:pPr>
             <a:r>
-              <a:rPr lang="en-US" sz="2600" b="1" dirty="0">
-                <a:solidFill>
-                  <a:srgbClr val="8A8A8A"/>
+              <a:rPr lang="en-US" sz="3600" b="1" dirty="0">
+                <a:solidFill>
+                  <a:srgbClr val="BBBBBB"/>
                 </a:solidFill>
                 <a:latin typeface="Arial" pitchFamily="34" charset="0"/>
                 <a:ea typeface="Arial" pitchFamily="34" charset="-122"/>
@@ -3000,7 +3000,7 @@
               </a:rPr>
               <a:t>×2</a:t>
             </a:r>
-            <a:endParaRPr lang="en-US" sz="2600" dirty="0"/>
+            <a:endParaRPr lang="en-US" sz="3600" dirty="0"/>
           </a:p>
         </p:txBody>
       </p:sp>
@@ -3268,7 +3268,7 @@
         </p:nvSpPr>
         <p:spPr>
           <a:xfrm>
-            <a:off x="1629791" y="4340352"/>
+            <a:off x="1728851" y="4340352"/>
             <a:ext cx="0" cy="594360"/>
           </a:xfrm>
           <a:prstGeom prst="line">
@@ -3291,7 +3291,7 @@
         </p:nvSpPr>
         <p:spPr>
           <a:xfrm>
-            <a:off x="10568305" y="4340352"/>
+            <a:off x="10469245" y="4340352"/>
             <a:ext cx="0" cy="594360"/>
           </a:xfrm>
           <a:prstGeom prst="line">
@@ -3314,8 +3314,8 @@
         </p:nvSpPr>
         <p:spPr>
           <a:xfrm>
-            <a:off x="10700385" y="4406392"/>
-            <a:ext cx="792480" cy="462280"/>
+            <a:off x="10568305" y="4317492"/>
+            <a:ext cx="1097280" cy="640080"/>
           </a:xfrm>
           <a:prstGeom prst="rect">
             <a:avLst/>
@@ -3331,9 +3331,9 @@
               <a:buNone/>
             </a:pPr>
             <a:r>
-              <a:rPr lang="en-US" sz="2600" b="1" dirty="0">
-                <a:solidFill>
-                  <a:srgbClr val="8A8A8A"/>
+              <a:rPr lang="en-US" sz="3600" b="1" dirty="0">
+                <a:solidFill>
+                  <a:srgbClr val="BBBBBB"/>
                 </a:solidFill>
                 <a:latin typeface="Arial" pitchFamily="34" charset="0"/>
                 <a:ea typeface="Arial" pitchFamily="34" charset="-122"/>
@@ -3341,7 +3341,7 @@
               </a:rPr>
               <a:t>×2</a:t>
             </a:r>
-            <a:endParaRPr lang="en-US" sz="2600" dirty="0"/>
+            <a:endParaRPr lang="en-US" sz="3600" dirty="0"/>
           </a:p>
         </p:txBody>
       </p:sp>
@@ -3609,7 +3609,7 @@
         </p:nvSpPr>
         <p:spPr>
           <a:xfrm>
-            <a:off x="1629791" y="4340352"/>
+            <a:off x="1728851" y="4340352"/>
             <a:ext cx="0" cy="594360"/>
           </a:xfrm>
           <a:prstGeom prst="line">
@@ -3632,7 +3632,7 @@
         </p:nvSpPr>
         <p:spPr>
           <a:xfrm>
-            <a:off x="10568305" y="4340352"/>
+            <a:off x="10469245" y="4340352"/>
             <a:ext cx="0" cy="594360"/>
           </a:xfrm>
           <a:prstGeom prst="line">
@@ -3655,8 +3655,8 @@
         </p:nvSpPr>
         <p:spPr>
           <a:xfrm>
-            <a:off x="10700385" y="4406392"/>
-            <a:ext cx="792480" cy="462280"/>
+            <a:off x="10568305" y="4317492"/>
+            <a:ext cx="1097280" cy="640080"/>
           </a:xfrm>
           <a:prstGeom prst="rect">
             <a:avLst/>
@@ -3672,9 +3672,9 @@
               <a:buNone/>
             </a:pPr>
             <a:r>
-              <a:rPr lang="en-US" sz="2600" b="1" dirty="0">
-                <a:solidFill>
-                  <a:srgbClr val="8A8A8A"/>
+              <a:rPr lang="en-US" sz="3600" b="1" dirty="0">
+                <a:solidFill>
+                  <a:srgbClr val="BBBBBB"/>
                 </a:solidFill>
                 <a:latin typeface="Arial" pitchFamily="34" charset="0"/>
                 <a:ea typeface="Arial" pitchFamily="34" charset="-122"/>
@@ -3682,7 +3682,7 @@
               </a:rPr>
               <a:t>×2</a:t>
             </a:r>
-            <a:endParaRPr lang="en-US" sz="2600" dirty="0"/>
+            <a:endParaRPr lang="en-US" sz="3600" dirty="0"/>
           </a:p>
         </p:txBody>
       </p:sp>

</xml_diff>